<commit_message>
Update README intro and platform architecture section, update pptx brand colors
</commit_message>
<xml_diff>
--- a/docs/Enterprise-Safe Copilot Orchestration for Azure Landing Zone Governance.pptx
+++ b/docs/Enterprise-Safe Copilot Orchestration for Azure Landing Zone Governance.pptx
@@ -3683,9 +3683,6 @@
           <a:bodyPr wrap="square" rtlCol="0" anchor="ctr"/>
           <a:lstStyle/>
           <a:p>
-            <a:pPr marL="0" indent="0">
-              <a:buNone/>
-            </a:pPr>
             <a:r>
               <a:rPr lang="en-US" sz="1400" dirty="0">
                 <a:solidFill>
@@ -3695,7 +3692,7 @@
                 <a:ea typeface="Segoe UI" pitchFamily="34" charset="-122"/>
                 <a:cs typeface="Segoe UI" pitchFamily="34" charset="-120"/>
               </a:rPr>
-              <a:t>Repeatable. Deterministic. Enterprise‑safe guardrails for CSA‑led engagements.</a:t>
+              <a:t>Repeatable. Deterministic. Enterprise‑safe guardrails for CSA‑led engagements</a:t>
             </a:r>
             <a:endParaRPr lang="en-US" sz="1400" dirty="0"/>
           </a:p>
@@ -32757,9 +32754,38 @@
           <a:bodyPr wrap="square" rtlCol="0" anchor="ctr"/>
           <a:lstStyle/>
           <a:p>
-            <a:pPr marL="0" indent="0" algn="ctr">
-              <a:buNone/>
-            </a:pPr>
+            <a:pPr algn="ctr"/>
+            <a:r>
+              <a:rPr lang="en-US" sz="1200" dirty="0">
+                <a:latin typeface="Segoe UI" panose="020B0502040204020203" pitchFamily="34" charset="0"/>
+                <a:cs typeface="Segoe UI" panose="020B0502040204020203" pitchFamily="34" charset="0"/>
+                <a:hlinkClick r:id="rId3"/>
+              </a:rPr>
+              <a:t>Git Repo: </a:t>
+            </a:r>
+            <a:r>
+              <a:rPr lang="en-US" sz="1200" dirty="0" err="1">
+                <a:latin typeface="Segoe UI" panose="020B0502040204020203" pitchFamily="34" charset="0"/>
+                <a:cs typeface="Segoe UI" panose="020B0502040204020203" pitchFamily="34" charset="0"/>
+                <a:hlinkClick r:id="rId3"/>
+              </a:rPr>
+              <a:t>rebmid</a:t>
+            </a:r>
+            <a:r>
+              <a:rPr lang="en-US" sz="1200" dirty="0">
+                <a:latin typeface="Segoe UI" panose="020B0502040204020203" pitchFamily="34" charset="0"/>
+                <a:cs typeface="Segoe UI" panose="020B0502040204020203" pitchFamily="34" charset="0"/>
+                <a:hlinkClick r:id="rId3"/>
+              </a:rPr>
+              <a:t>/Copilot-alz-workshop-orchestrator </a:t>
+            </a:r>
+            <a:r>
+              <a:rPr lang="en-US" sz="1200" dirty="0">
+                <a:latin typeface="Segoe UI" panose="020B0502040204020203" pitchFamily="34" charset="0"/>
+                <a:cs typeface="Segoe UI" panose="020B0502040204020203" pitchFamily="34" charset="0"/>
+              </a:rPr>
+              <a:t> </a:t>
+            </a:r>
             <a:r>
               <a:rPr lang="en-US" sz="1200" b="1" dirty="0">
                 <a:solidFill>

</xml_diff>

<commit_message>
Add CI/CD to architecture, add summary.md, update pptx brand colors
</commit_message>
<xml_diff>
--- a/docs/Enterprise-Safe Copilot Orchestration for Azure Landing Zone Governance.pptx
+++ b/docs/Enterprise-Safe Copilot Orchestration for Azure Landing Zone Governance.pptx
@@ -15877,11 +15877,9 @@
           <a:bodyPr wrap="square" rtlCol="0" anchor="ctr"/>
           <a:lstStyle/>
           <a:p>
-            <a:pPr marL="0" indent="0" algn="ctr">
-              <a:buNone/>
-            </a:pPr>
+            <a:pPr algn="ctr"/>
             <a:r>
-              <a:rPr lang="en-US" sz="1150" b="1" dirty="0">
+              <a:rPr lang="en-US" sz="1150" b="1">
                 <a:solidFill>
                   <a:srgbClr val="104581"/>
                 </a:solidFill>
@@ -15889,7 +15887,7 @@
                 <a:ea typeface="Segoe UI" pitchFamily="34" charset="-122"/>
                 <a:cs typeface="Segoe UI" pitchFamily="34" charset="-120"/>
               </a:rPr>
-              <a:t>One‑way data flow:  Azure → Deterministic Engine → Copilot → Structured Outputs  (read‑only, governed, auditable)</a:t>
+              <a:t>Governed data flow: Azure → Deterministic Engine → Copilot Orchestration → Enterprise Outputs</a:t>
             </a:r>
             <a:endParaRPr lang="en-US" sz="1150" dirty="0"/>
           </a:p>
@@ -30610,7 +30608,7 @@
         </p:nvSpPr>
         <p:spPr>
           <a:xfrm>
-            <a:off x="8897112" y="5486400"/>
+            <a:off x="8897112" y="5437047"/>
             <a:ext cx="2642616" cy="237744"/>
           </a:xfrm>
           <a:prstGeom prst="rect">
@@ -30649,8 +30647,8 @@
         </p:nvSpPr>
         <p:spPr>
           <a:xfrm>
-            <a:off x="8933688" y="5760720"/>
-            <a:ext cx="2569464" cy="713232"/>
+            <a:off x="8906217" y="5604144"/>
+            <a:ext cx="2659913" cy="713232"/>
           </a:xfrm>
           <a:prstGeom prst="rect">
             <a:avLst/>
@@ -30666,7 +30664,7 @@
               <a:buNone/>
             </a:pPr>
             <a:r>
-              <a:rPr lang="en-US" sz="1100" dirty="0">
+              <a:rPr lang="en-US" sz="1030" dirty="0">
                 <a:solidFill>
                   <a:srgbClr val="2B2B2B"/>
                 </a:solidFill>
@@ -30674,77 +30672,111 @@
                 <a:ea typeface="Segoe UI" pitchFamily="34" charset="-122"/>
                 <a:cs typeface="Segoe UI" pitchFamily="34" charset="-120"/>
               </a:rPr>
-              <a:t>• HTML Executive Report</a:t>
+              <a:t>• </a:t>
             </a:r>
-            <a:endParaRPr lang="en-US" sz="1100" dirty="0"/>
+            <a:r>
+              <a:rPr lang="en-US" sz="1030" dirty="0">
+                <a:solidFill>
+                  <a:srgbClr val="2B2B2B"/>
+                </a:solidFill>
+                <a:latin typeface="Segoe UI" panose="020B0502040204020203" pitchFamily="34" charset="0"/>
+                <a:ea typeface="Segoe UI" pitchFamily="34" charset="-122"/>
+                <a:cs typeface="Segoe UI" panose="020B0502040204020203" pitchFamily="34" charset="0"/>
+              </a:rPr>
+              <a:t>HTML Executive Report</a:t>
+            </a:r>
+            <a:endParaRPr lang="en-US" sz="1030" dirty="0">
+              <a:latin typeface="Segoe UI" panose="020B0502040204020203" pitchFamily="34" charset="0"/>
+              <a:cs typeface="Segoe UI" panose="020B0502040204020203" pitchFamily="34" charset="0"/>
+            </a:endParaRPr>
           </a:p>
           <a:p>
             <a:pPr marL="0" indent="0">
               <a:buNone/>
             </a:pPr>
             <a:r>
-              <a:rPr lang="en-US" sz="1100" dirty="0">
+              <a:rPr lang="en-US" sz="1030" dirty="0">
                 <a:solidFill>
                   <a:srgbClr val="2B2B2B"/>
                 </a:solidFill>
-                <a:latin typeface="Segoe UI" pitchFamily="34" charset="0"/>
+                <a:latin typeface="Segoe UI" panose="020B0502040204020203" pitchFamily="34" charset="0"/>
                 <a:ea typeface="Segoe UI" pitchFamily="34" charset="-122"/>
-                <a:cs typeface="Segoe UI" pitchFamily="34" charset="-120"/>
+                <a:cs typeface="Segoe UI" panose="020B0502040204020203" pitchFamily="34" charset="0"/>
               </a:rPr>
               <a:t>• Excel CSA Workbook</a:t>
             </a:r>
-            <a:endParaRPr lang="en-US" sz="1100" dirty="0"/>
+            <a:endParaRPr lang="en-US" sz="1030" dirty="0">
+              <a:latin typeface="Segoe UI" panose="020B0502040204020203" pitchFamily="34" charset="0"/>
+              <a:cs typeface="Segoe UI" panose="020B0502040204020203" pitchFamily="34" charset="0"/>
+            </a:endParaRPr>
           </a:p>
           <a:p>
             <a:pPr marL="0" indent="0">
               <a:buNone/>
             </a:pPr>
             <a:r>
-              <a:rPr lang="en-US" sz="1100" dirty="0">
+              <a:rPr lang="en-US" sz="1030" dirty="0">
                 <a:solidFill>
                   <a:srgbClr val="2B2B2B"/>
                 </a:solidFill>
-                <a:latin typeface="Segoe UI" pitchFamily="34" charset="0"/>
+                <a:latin typeface="Segoe UI" panose="020B0502040204020203" pitchFamily="34" charset="0"/>
                 <a:ea typeface="Segoe UI" pitchFamily="34" charset="-122"/>
-                <a:cs typeface="Segoe UI" pitchFamily="34" charset="-120"/>
+                <a:cs typeface="Segoe UI" panose="020B0502040204020203" pitchFamily="34" charset="0"/>
               </a:rPr>
               <a:t>• JSON Artifact</a:t>
             </a:r>
-            <a:endParaRPr lang="en-US" sz="1100" dirty="0"/>
+            <a:endParaRPr lang="en-US" sz="1030" dirty="0">
+              <a:latin typeface="Segoe UI" panose="020B0502040204020203" pitchFamily="34" charset="0"/>
+              <a:cs typeface="Segoe UI" panose="020B0502040204020203" pitchFamily="34" charset="0"/>
+            </a:endParaRPr>
           </a:p>
           <a:p>
             <a:pPr marL="0" indent="0">
               <a:buNone/>
             </a:pPr>
             <a:r>
-              <a:rPr lang="en-US" sz="1100" dirty="0">
+              <a:rPr lang="en-US" sz="1030" dirty="0">
                 <a:solidFill>
                   <a:srgbClr val="2B2B2B"/>
                 </a:solidFill>
-                <a:latin typeface="Segoe UI" pitchFamily="34" charset="0"/>
+                <a:latin typeface="Segoe UI" panose="020B0502040204020203" pitchFamily="34" charset="0"/>
                 <a:ea typeface="Segoe UI" pitchFamily="34" charset="-122"/>
-                <a:cs typeface="Segoe UI" pitchFamily="34" charset="-120"/>
+                <a:cs typeface="Segoe UI" panose="020B0502040204020203" pitchFamily="34" charset="0"/>
               </a:rPr>
-              <a:t>• Workshop Dialogue</a:t>
+              <a:t>• </a:t>
             </a:r>
-            <a:endParaRPr lang="en-US" sz="1100" dirty="0"/>
-          </a:p>
-          <a:p>
-            <a:pPr marL="0" indent="0">
-              <a:buNone/>
-            </a:pPr>
             <a:r>
-              <a:rPr lang="en-US" sz="1100" dirty="0">
+              <a:rPr lang="en-US" sz="1030" dirty="0">
                 <a:solidFill>
                   <a:srgbClr val="2B2B2B"/>
                 </a:solidFill>
-                <a:latin typeface="Segoe UI" pitchFamily="34" charset="0"/>
-                <a:ea typeface="Segoe UI" pitchFamily="34" charset="-122"/>
-                <a:cs typeface="Segoe UI" pitchFamily="34" charset="-120"/>
+                <a:latin typeface="Segoe UI" panose="020B0502040204020203" pitchFamily="34" charset="0"/>
+                <a:cs typeface="Segoe UI" panose="020B0502040204020203" pitchFamily="34" charset="0"/>
               </a:rPr>
-              <a:t>• GitHub Issues (CI Mode)</a:t>
+              <a:t>Workshop Dialogue</a:t>
             </a:r>
-            <a:endParaRPr lang="en-US" sz="1100" dirty="0"/>
+          </a:p>
+          <a:p>
+            <a:r>
+              <a:rPr lang="en-US" sz="1030" dirty="0">
+                <a:solidFill>
+                  <a:srgbClr val="2B2B2B"/>
+                </a:solidFill>
+                <a:latin typeface="Segoe UI" panose="020B0502040204020203" pitchFamily="34" charset="0"/>
+                <a:cs typeface="Segoe UI" panose="020B0502040204020203" pitchFamily="34" charset="0"/>
+              </a:rPr>
+              <a:t>• CI/CD Posture Artifacts (GitHub </a:t>
+            </a:r>
+            <a:r>
+              <a:rPr lang="en-US" sz="1050" dirty="0">
+                <a:solidFill>
+                  <a:srgbClr val="2B2B2B"/>
+                </a:solidFill>
+                <a:latin typeface="Segoe UI" panose="020B0502040204020203" pitchFamily="34" charset="0"/>
+                <a:cs typeface="Segoe UI" panose="020B0502040204020203" pitchFamily="34" charset="0"/>
+              </a:rPr>
+              <a:t>Actions)</a:t>
+            </a:r>
           </a:p>
         </p:txBody>
       </p:sp>

</xml_diff>

<commit_message>
Update demo images, sample report, and presentation deck
</commit_message>
<xml_diff>
--- a/docs/Enterprise-Safe Copilot Orchestration for Azure Landing Zone Governance.pptx
+++ b/docs/Enterprise-Safe Copilot Orchestration for Azure Landing Zone Governance.pptx
@@ -7739,7 +7739,7 @@
           <a:bodyPr wrap="square" rtlCol="0" anchor="t"/>
           <a:lstStyle/>
           <a:p>
-            <a:pPr marL="285750" indent="-285750">
+            <a:pPr marL="285750" indent="-285750" fontAlgn="t">
               <a:lnSpc>
                 <a:spcPct val="115000"/>
               </a:lnSpc>
@@ -7755,12 +7755,10 @@
                   <a:srgbClr val="2B2B2B"/>
                 </a:solidFill>
                 <a:latin typeface="Segoe UI" pitchFamily="34" charset="0"/>
-                <a:ea typeface="Segoe UI" pitchFamily="34" charset="-122"/>
                 <a:cs typeface="Segoe UI" pitchFamily="34" charset="-120"/>
               </a:rPr>
-              <a:t>Intent‑scoped workshops (reduce “run everything” noise)</a:t>
+              <a:t>Intent‑scoped workshops reduce “run everything” noise</a:t>
             </a:r>
-            <a:endParaRPr lang="en-US" sz="1250" dirty="0"/>
           </a:p>
           <a:p>
             <a:pPr marL="285750" indent="-285750">
@@ -7804,7 +7802,7 @@
                 <a:ea typeface="Segoe UI" pitchFamily="34" charset="-122"/>
                 <a:cs typeface="Segoe UI" pitchFamily="34" charset="-120"/>
               </a:rPr>
-              <a:t>+ domain summaries</a:t>
+              <a:t>with domain-level summaries</a:t>
             </a:r>
             <a:endParaRPr lang="en-US" sz="1250" dirty="0"/>
           </a:p>
@@ -9678,18 +9676,7 @@
                 <a:ea typeface="Segoe UI" pitchFamily="34" charset="-122"/>
                 <a:cs typeface="Segoe UI" pitchFamily="34" charset="-120"/>
               </a:rPr>
-              <a:t>Deterministic </a:t>
-            </a:r>
-            <a:r>
-              <a:rPr lang="en-US" sz="1250">
-                <a:solidFill>
-                  <a:srgbClr val="2B2B2B"/>
-                </a:solidFill>
-                <a:latin typeface="Segoe UI" pitchFamily="34" charset="0"/>
-                <a:ea typeface="Segoe UI" pitchFamily="34" charset="-122"/>
-                <a:cs typeface="Segoe UI" pitchFamily="34" charset="-120"/>
-              </a:rPr>
-              <a:t>engine is </a:t>
+              <a:t>Deterministic engine is </a:t>
             </a:r>
             <a:r>
               <a:rPr lang="en-US" sz="1250" b="1" dirty="0">
@@ -9759,7 +9746,7 @@
                 <a:ea typeface="Segoe UI" pitchFamily="34" charset="-122"/>
                 <a:cs typeface="Segoe UI" pitchFamily="34" charset="-120"/>
               </a:rPr>
-              <a:t>Tool‑restricted orchestration (no arbitrary shell, no mutation)</a:t>
+              <a:t>Tool‑restricted orchestration (no arbitrary shell or mutation)</a:t>
             </a:r>
             <a:endParaRPr lang="en-US" sz="1250" dirty="0"/>
           </a:p>
@@ -11609,7 +11596,7 @@
                 <a:ea typeface="Segoe UI" pitchFamily="34" charset="-122"/>
                 <a:cs typeface="Segoe UI" pitchFamily="34" charset="-120"/>
               </a:rPr>
-              <a:t>Manual interviews → Guided orchestration</a:t>
+              <a:t>Manual interviews → Guided, intent-driven orchestration</a:t>
             </a:r>
             <a:endParaRPr lang="en-US" sz="1250" dirty="0"/>
           </a:p>
@@ -11644,9 +11631,20 @@
                 <a:ea typeface="Segoe UI" pitchFamily="34" charset="-122"/>
                 <a:cs typeface="Segoe UI" pitchFamily="34" charset="-120"/>
               </a:rPr>
-              <a:t>Deterministic deltas</a:t>
+              <a:t>Deterministic deltas </a:t>
             </a:r>
-            <a:endParaRPr lang="en-US" sz="1250" b="1" dirty="0"/>
+            <a:r>
+              <a:rPr lang="en-US" sz="1250" dirty="0">
+                <a:solidFill>
+                  <a:srgbClr val="2B2B2B"/>
+                </a:solidFill>
+                <a:latin typeface="Segoe UI" pitchFamily="34" charset="0"/>
+                <a:ea typeface="Segoe UI" pitchFamily="34" charset="-122"/>
+                <a:cs typeface="Segoe UI" pitchFamily="34" charset="-120"/>
+              </a:rPr>
+              <a:t>over time</a:t>
+            </a:r>
+            <a:endParaRPr lang="en-US" sz="1250" dirty="0"/>
           </a:p>
           <a:p>
             <a:pPr marL="285750" indent="-285750">
@@ -13542,7 +13540,7 @@
                 <a:ea typeface="Segoe UI" pitchFamily="34" charset="-122"/>
                 <a:cs typeface="Segoe UI" pitchFamily="34" charset="-120"/>
               </a:rPr>
-              <a:t>Continuous posture (CI/CD): scheduled runs + delta + tracking artifacts</a:t>
+              <a:t>Continuous posture (CI/CD): scheduled runs with delta + artifact tracking</a:t>
             </a:r>
             <a:endParaRPr lang="en-US" sz="1250" dirty="0"/>
           </a:p>
@@ -21694,8 +21692,8 @@
         </p:nvSpPr>
         <p:spPr>
           <a:xfrm>
-            <a:off x="3995928" y="2029967"/>
-            <a:ext cx="4215384" cy="324925"/>
+            <a:off x="3794801" y="2029967"/>
+            <a:ext cx="4829134" cy="324925"/>
           </a:xfrm>
           <a:prstGeom prst="rect">
             <a:avLst/>
@@ -21711,7 +21709,7 @@
               <a:buNone/>
             </a:pPr>
             <a:r>
-              <a:rPr lang="en-US" sz="1050" dirty="0">
+              <a:rPr lang="en-US" sz="1000" dirty="0">
                 <a:solidFill>
                   <a:srgbClr val="2B2B2B"/>
                 </a:solidFill>
@@ -21719,9 +21717,9 @@
                 <a:ea typeface="Segoe UI" pitchFamily="34" charset="-122"/>
                 <a:cs typeface="Segoe UI" pitchFamily="34" charset="-120"/>
               </a:rPr>
-              <a:t>• Intent Router     • Guardrailed Tool Calls     • Multi‑Turn Workshop</a:t>
+              <a:t>• Intent Router  • Guardrailed Tool Calls   • Multi‑Turn Workshop Orchestration</a:t>
             </a:r>
-            <a:endParaRPr lang="en-US" sz="1050" dirty="0"/>
+            <a:endParaRPr lang="en-US" sz="1000" dirty="0"/>
           </a:p>
         </p:txBody>
       </p:sp>
@@ -27407,7 +27405,7 @@
                 <a:ea typeface="Segoe UI" pitchFamily="34" charset="-122"/>
                 <a:cs typeface="Segoe UI" pitchFamily="34" charset="-120"/>
               </a:rPr>
-              <a:t>• Collectors</a:t>
+              <a:t>• Read-only Collectors</a:t>
             </a:r>
             <a:endParaRPr lang="en-US" sz="1100" dirty="0"/>
           </a:p>
@@ -32816,7 +32814,7 @@
                 <a:latin typeface="Segoe UI" panose="020B0502040204020203" pitchFamily="34" charset="0"/>
                 <a:cs typeface="Segoe UI" panose="020B0502040204020203" pitchFamily="34" charset="0"/>
               </a:rPr>
-              <a:t> </a:t>
+              <a:t>  </a:t>
             </a:r>
             <a:r>
               <a:rPr lang="en-US" sz="1200" b="1" dirty="0">

</xml_diff>

<commit_message>
Update demo images, sample report, and presentation deck (#25)
* report/design-Azure-palette: Azure portal design language, bug fixes

- Report CSS: Azure Blue (#0078D4) nav, Dark Azure (#005A9E) headings, #F3F6F9 bg, white card sections with box-shadow
- Trajectory bar: single Azure Blue bar with #605E5C milestone markers, fallback from empty deterministic to LLM trajectory
- Critical issues (S6): extract from ai.critical_issues in render.py, add to demo fixtures
- Excel export: write cached run to out/ when file path can't be resolved by run_id
- Workshop SDK: fix PermissionHandler.approve_all -> lambda for copilot SDK v0.1.0
- scan.py: fix box-drawing alignment for banner
- Font stack: Segoe UI first per Azure design rules
- Status colors: #107C10 pass, #FFB900 warning, #D13438 fail

* Add sample critical issues to demo fixtures for section 6 content

* Add Demo Mode section to README for hackathon judges

* Update demo images, sample report, and presentation deck
</commit_message>
<xml_diff>
--- a/docs/Enterprise-Safe Copilot Orchestration for Azure Landing Zone Governance.pptx
+++ b/docs/Enterprise-Safe Copilot Orchestration for Azure Landing Zone Governance.pptx
@@ -7739,7 +7739,7 @@
           <a:bodyPr wrap="square" rtlCol="0" anchor="t"/>
           <a:lstStyle/>
           <a:p>
-            <a:pPr marL="285750" indent="-285750">
+            <a:pPr marL="285750" indent="-285750" fontAlgn="t">
               <a:lnSpc>
                 <a:spcPct val="115000"/>
               </a:lnSpc>
@@ -7755,12 +7755,10 @@
                   <a:srgbClr val="2B2B2B"/>
                 </a:solidFill>
                 <a:latin typeface="Segoe UI" pitchFamily="34" charset="0"/>
-                <a:ea typeface="Segoe UI" pitchFamily="34" charset="-122"/>
                 <a:cs typeface="Segoe UI" pitchFamily="34" charset="-120"/>
               </a:rPr>
-              <a:t>Intent‑scoped workshops (reduce “run everything” noise)</a:t>
+              <a:t>Intent‑scoped workshops reduce “run everything” noise</a:t>
             </a:r>
-            <a:endParaRPr lang="en-US" sz="1250" dirty="0"/>
           </a:p>
           <a:p>
             <a:pPr marL="285750" indent="-285750">
@@ -7804,7 +7802,7 @@
                 <a:ea typeface="Segoe UI" pitchFamily="34" charset="-122"/>
                 <a:cs typeface="Segoe UI" pitchFamily="34" charset="-120"/>
               </a:rPr>
-              <a:t>+ domain summaries</a:t>
+              <a:t>with domain-level summaries</a:t>
             </a:r>
             <a:endParaRPr lang="en-US" sz="1250" dirty="0"/>
           </a:p>
@@ -9678,18 +9676,7 @@
                 <a:ea typeface="Segoe UI" pitchFamily="34" charset="-122"/>
                 <a:cs typeface="Segoe UI" pitchFamily="34" charset="-120"/>
               </a:rPr>
-              <a:t>Deterministic </a:t>
-            </a:r>
-            <a:r>
-              <a:rPr lang="en-US" sz="1250">
-                <a:solidFill>
-                  <a:srgbClr val="2B2B2B"/>
-                </a:solidFill>
-                <a:latin typeface="Segoe UI" pitchFamily="34" charset="0"/>
-                <a:ea typeface="Segoe UI" pitchFamily="34" charset="-122"/>
-                <a:cs typeface="Segoe UI" pitchFamily="34" charset="-120"/>
-              </a:rPr>
-              <a:t>engine is </a:t>
+              <a:t>Deterministic engine is </a:t>
             </a:r>
             <a:r>
               <a:rPr lang="en-US" sz="1250" b="1" dirty="0">
@@ -9759,7 +9746,7 @@
                 <a:ea typeface="Segoe UI" pitchFamily="34" charset="-122"/>
                 <a:cs typeface="Segoe UI" pitchFamily="34" charset="-120"/>
               </a:rPr>
-              <a:t>Tool‑restricted orchestration (no arbitrary shell, no mutation)</a:t>
+              <a:t>Tool‑restricted orchestration (no arbitrary shell or mutation)</a:t>
             </a:r>
             <a:endParaRPr lang="en-US" sz="1250" dirty="0"/>
           </a:p>
@@ -11609,7 +11596,7 @@
                 <a:ea typeface="Segoe UI" pitchFamily="34" charset="-122"/>
                 <a:cs typeface="Segoe UI" pitchFamily="34" charset="-120"/>
               </a:rPr>
-              <a:t>Manual interviews → Guided orchestration</a:t>
+              <a:t>Manual interviews → Guided, intent-driven orchestration</a:t>
             </a:r>
             <a:endParaRPr lang="en-US" sz="1250" dirty="0"/>
           </a:p>
@@ -11644,9 +11631,20 @@
                 <a:ea typeface="Segoe UI" pitchFamily="34" charset="-122"/>
                 <a:cs typeface="Segoe UI" pitchFamily="34" charset="-120"/>
               </a:rPr>
-              <a:t>Deterministic deltas</a:t>
+              <a:t>Deterministic deltas </a:t>
             </a:r>
-            <a:endParaRPr lang="en-US" sz="1250" b="1" dirty="0"/>
+            <a:r>
+              <a:rPr lang="en-US" sz="1250" dirty="0">
+                <a:solidFill>
+                  <a:srgbClr val="2B2B2B"/>
+                </a:solidFill>
+                <a:latin typeface="Segoe UI" pitchFamily="34" charset="0"/>
+                <a:ea typeface="Segoe UI" pitchFamily="34" charset="-122"/>
+                <a:cs typeface="Segoe UI" pitchFamily="34" charset="-120"/>
+              </a:rPr>
+              <a:t>over time</a:t>
+            </a:r>
+            <a:endParaRPr lang="en-US" sz="1250" dirty="0"/>
           </a:p>
           <a:p>
             <a:pPr marL="285750" indent="-285750">
@@ -13542,7 +13540,7 @@
                 <a:ea typeface="Segoe UI" pitchFamily="34" charset="-122"/>
                 <a:cs typeface="Segoe UI" pitchFamily="34" charset="-120"/>
               </a:rPr>
-              <a:t>Continuous posture (CI/CD): scheduled runs + delta + tracking artifacts</a:t>
+              <a:t>Continuous posture (CI/CD): scheduled runs with delta + artifact tracking</a:t>
             </a:r>
             <a:endParaRPr lang="en-US" sz="1250" dirty="0"/>
           </a:p>
@@ -21694,8 +21692,8 @@
         </p:nvSpPr>
         <p:spPr>
           <a:xfrm>
-            <a:off x="3995928" y="2029967"/>
-            <a:ext cx="4215384" cy="324925"/>
+            <a:off x="3794801" y="2029967"/>
+            <a:ext cx="4829134" cy="324925"/>
           </a:xfrm>
           <a:prstGeom prst="rect">
             <a:avLst/>
@@ -21711,7 +21709,7 @@
               <a:buNone/>
             </a:pPr>
             <a:r>
-              <a:rPr lang="en-US" sz="1050" dirty="0">
+              <a:rPr lang="en-US" sz="1000" dirty="0">
                 <a:solidFill>
                   <a:srgbClr val="2B2B2B"/>
                 </a:solidFill>
@@ -21719,9 +21717,9 @@
                 <a:ea typeface="Segoe UI" pitchFamily="34" charset="-122"/>
                 <a:cs typeface="Segoe UI" pitchFamily="34" charset="-120"/>
               </a:rPr>
-              <a:t>• Intent Router     • Guardrailed Tool Calls     • Multi‑Turn Workshop</a:t>
+              <a:t>• Intent Router  • Guardrailed Tool Calls   • Multi‑Turn Workshop Orchestration</a:t>
             </a:r>
-            <a:endParaRPr lang="en-US" sz="1050" dirty="0"/>
+            <a:endParaRPr lang="en-US" sz="1000" dirty="0"/>
           </a:p>
         </p:txBody>
       </p:sp>
@@ -27407,7 +27405,7 @@
                 <a:ea typeface="Segoe UI" pitchFamily="34" charset="-122"/>
                 <a:cs typeface="Segoe UI" pitchFamily="34" charset="-120"/>
               </a:rPr>
-              <a:t>• Collectors</a:t>
+              <a:t>• Read-only Collectors</a:t>
             </a:r>
             <a:endParaRPr lang="en-US" sz="1100" dirty="0"/>
           </a:p>
@@ -32816,7 +32814,7 @@
                 <a:latin typeface="Segoe UI" panose="020B0502040204020203" pitchFamily="34" charset="0"/>
                 <a:cs typeface="Segoe UI" panose="020B0502040204020203" pitchFamily="34" charset="0"/>
               </a:rPr>
-              <a:t> </a:t>
+              <a:t>  </a:t>
             </a:r>
             <a:r>
               <a:rPr lang="en-US" sz="1200" b="1" dirty="0">

</xml_diff>